<commit_message>
boards/driver-shield: Fix driver shield pinout.
</commit_message>
<xml_diff>
--- a/boards/driver-shield/driver-shield-pinout.pptx
+++ b/boards/driver-shield/driver-shield-pinout.pptx
@@ -241,7 +241,7 @@
           <a:p>
             <a:fld id="{C4837162-BF4A-4F96-959A-FC5D79B042DC}" type="datetimeFigureOut">
               <a:rPr lang="en-US" smtClean="0"/>
-              <a:t>4/19/2024</a:t>
+              <a:t>5/8/2026</a:t>
             </a:fld>
             <a:endParaRPr lang="en-US"/>
           </a:p>
@@ -409,7 +409,7 @@
           <a:p>
             <a:fld id="{C4837162-BF4A-4F96-959A-FC5D79B042DC}" type="datetimeFigureOut">
               <a:rPr lang="en-US" smtClean="0"/>
-              <a:t>4/19/2024</a:t>
+              <a:t>5/8/2026</a:t>
             </a:fld>
             <a:endParaRPr lang="en-US"/>
           </a:p>
@@ -587,7 +587,7 @@
           <a:p>
             <a:fld id="{C4837162-BF4A-4F96-959A-FC5D79B042DC}" type="datetimeFigureOut">
               <a:rPr lang="en-US" smtClean="0"/>
-              <a:t>4/19/2024</a:t>
+              <a:t>5/8/2026</a:t>
             </a:fld>
             <a:endParaRPr lang="en-US"/>
           </a:p>
@@ -755,7 +755,7 @@
           <a:p>
             <a:fld id="{C4837162-BF4A-4F96-959A-FC5D79B042DC}" type="datetimeFigureOut">
               <a:rPr lang="en-US" smtClean="0"/>
-              <a:t>4/19/2024</a:t>
+              <a:t>5/8/2026</a:t>
             </a:fld>
             <a:endParaRPr lang="en-US"/>
           </a:p>
@@ -1000,7 +1000,7 @@
           <a:p>
             <a:fld id="{C4837162-BF4A-4F96-959A-FC5D79B042DC}" type="datetimeFigureOut">
               <a:rPr lang="en-US" smtClean="0"/>
-              <a:t>4/19/2024</a:t>
+              <a:t>5/8/2026</a:t>
             </a:fld>
             <a:endParaRPr lang="en-US"/>
           </a:p>
@@ -1229,7 +1229,7 @@
           <a:p>
             <a:fld id="{C4837162-BF4A-4F96-959A-FC5D79B042DC}" type="datetimeFigureOut">
               <a:rPr lang="en-US" smtClean="0"/>
-              <a:t>4/19/2024</a:t>
+              <a:t>5/8/2026</a:t>
             </a:fld>
             <a:endParaRPr lang="en-US"/>
           </a:p>
@@ -1593,7 +1593,7 @@
           <a:p>
             <a:fld id="{C4837162-BF4A-4F96-959A-FC5D79B042DC}" type="datetimeFigureOut">
               <a:rPr lang="en-US" smtClean="0"/>
-              <a:t>4/19/2024</a:t>
+              <a:t>5/8/2026</a:t>
             </a:fld>
             <a:endParaRPr lang="en-US"/>
           </a:p>
@@ -1710,7 +1710,7 @@
           <a:p>
             <a:fld id="{C4837162-BF4A-4F96-959A-FC5D79B042DC}" type="datetimeFigureOut">
               <a:rPr lang="en-US" smtClean="0"/>
-              <a:t>4/19/2024</a:t>
+              <a:t>5/8/2026</a:t>
             </a:fld>
             <a:endParaRPr lang="en-US"/>
           </a:p>
@@ -1805,7 +1805,7 @@
           <a:p>
             <a:fld id="{C4837162-BF4A-4F96-959A-FC5D79B042DC}" type="datetimeFigureOut">
               <a:rPr lang="en-US" smtClean="0"/>
-              <a:t>4/19/2024</a:t>
+              <a:t>5/8/2026</a:t>
             </a:fld>
             <a:endParaRPr lang="en-US"/>
           </a:p>
@@ -2080,7 +2080,7 @@
           <a:p>
             <a:fld id="{C4837162-BF4A-4F96-959A-FC5D79B042DC}" type="datetimeFigureOut">
               <a:rPr lang="en-US" smtClean="0"/>
-              <a:t>4/19/2024</a:t>
+              <a:t>5/8/2026</a:t>
             </a:fld>
             <a:endParaRPr lang="en-US"/>
           </a:p>
@@ -2332,7 +2332,7 @@
           <a:p>
             <a:fld id="{C4837162-BF4A-4F96-959A-FC5D79B042DC}" type="datetimeFigureOut">
               <a:rPr lang="en-US" smtClean="0"/>
-              <a:t>4/19/2024</a:t>
+              <a:t>5/8/2026</a:t>
             </a:fld>
             <a:endParaRPr lang="en-US"/>
           </a:p>
@@ -2543,7 +2543,7 @@
           <a:p>
             <a:fld id="{C4837162-BF4A-4F96-959A-FC5D79B042DC}" type="datetimeFigureOut">
               <a:rPr lang="en-US" smtClean="0"/>
-              <a:t>4/19/2024</a:t>
+              <a:t>5/8/2026</a:t>
             </a:fld>
             <a:endParaRPr lang="en-US"/>
           </a:p>
@@ -4012,7 +4012,7 @@
                     <a:pPr algn="ctr"/>
                     <a:r>
                       <a:rPr lang="en-US" sz="1600" dirty="0"/>
-                      <a:t>P0 DIR (O1/O2) (default)</a:t>
+                      <a:t>P0 DIR (O1/O2)</a:t>
                     </a:r>
                   </a:p>
                 </p:txBody>
@@ -4053,7 +4053,7 @@
                     <a:pPr algn="ctr"/>
                     <a:r>
                       <a:rPr lang="en-US" sz="1600" dirty="0"/>
-                      <a:t>P1 DIR (O1/O2) (alternative)</a:t>
+                      <a:t>P1 DIR (O3/O4) (alternative)</a:t>
                     </a:r>
                   </a:p>
                 </p:txBody>
@@ -4066,7 +4066,7 @@
                 </p:nvSpPr>
                 <p:spPr>
                   <a:xfrm>
-                    <a:off x="457200" y="3175371"/>
+                    <a:off x="457200" y="3533178"/>
                     <a:ext cx="2743200" cy="253629"/>
                   </a:xfrm>
                   <a:prstGeom prst="roundRect">
@@ -4189,7 +4189,7 @@
                 </p:nvSpPr>
                 <p:spPr>
                   <a:xfrm>
-                    <a:off x="457200" y="3520617"/>
+                    <a:off x="457200" y="3178715"/>
                     <a:ext cx="2743200" cy="253629"/>
                   </a:xfrm>
                   <a:prstGeom prst="roundRect">
@@ -4217,7 +4217,7 @@
                     <a:pPr algn="ctr"/>
                     <a:r>
                       <a:rPr lang="en-US" sz="1600" dirty="0"/>
-                      <a:t>P2 DIR (O3/O4) </a:t>
+                      <a:t>P2 DIR (O3/O4) (default)</a:t>
                     </a:r>
                   </a:p>
                 </p:txBody>

</xml_diff>